<commit_message>
new clear night pic
#66
</commit_message>
<xml_diff>
--- a/hmi/dev/ui/eu/NSPanel - EU.pptx
+++ b/hmi/dev/ui/eu/NSPanel - EU.pptx
@@ -6,10 +6,12 @@
   </p:sldMasterIdLst>
   <p:sldIdLst>
     <p:sldId id="258" r:id="rId2"/>
-    <p:sldId id="261" r:id="rId3"/>
-    <p:sldId id="259" r:id="rId4"/>
-    <p:sldId id="256" r:id="rId5"/>
-    <p:sldId id="257" r:id="rId6"/>
+    <p:sldId id="263" r:id="rId3"/>
+    <p:sldId id="261" r:id="rId4"/>
+    <p:sldId id="262" r:id="rId5"/>
+    <p:sldId id="259" r:id="rId6"/>
+    <p:sldId id="256" r:id="rId7"/>
+    <p:sldId id="257" r:id="rId8"/>
   </p:sldIdLst>
   <p:sldSz cx="4572000" cy="3048000"/>
   <p:notesSz cx="6858000" cy="9144000"/>
@@ -440,7 +442,7 @@
           <a:p>
             <a:fld id="{024B8AE9-66EA-4D6A-A8A7-9C9BEADD6B50}" type="datetimeFigureOut">
               <a:rPr lang="en-SE" smtClean="0"/>
-              <a:t>2024-02-01</a:t>
+              <a:t>2026-04-05</a:t>
             </a:fld>
             <a:endParaRPr lang="en-SE"/>
           </a:p>
@@ -610,7 +612,7 @@
           <a:p>
             <a:fld id="{024B8AE9-66EA-4D6A-A8A7-9C9BEADD6B50}" type="datetimeFigureOut">
               <a:rPr lang="en-SE" smtClean="0"/>
-              <a:t>2024-02-01</a:t>
+              <a:t>2026-04-05</a:t>
             </a:fld>
             <a:endParaRPr lang="en-SE"/>
           </a:p>
@@ -790,7 +792,7 @@
           <a:p>
             <a:fld id="{024B8AE9-66EA-4D6A-A8A7-9C9BEADD6B50}" type="datetimeFigureOut">
               <a:rPr lang="en-SE" smtClean="0"/>
-              <a:t>2024-02-01</a:t>
+              <a:t>2026-04-05</a:t>
             </a:fld>
             <a:endParaRPr lang="en-SE"/>
           </a:p>
@@ -960,7 +962,7 @@
           <a:p>
             <a:fld id="{024B8AE9-66EA-4D6A-A8A7-9C9BEADD6B50}" type="datetimeFigureOut">
               <a:rPr lang="en-SE" smtClean="0"/>
-              <a:t>2024-02-01</a:t>
+              <a:t>2026-04-05</a:t>
             </a:fld>
             <a:endParaRPr lang="en-SE"/>
           </a:p>
@@ -1204,7 +1206,7 @@
           <a:p>
             <a:fld id="{024B8AE9-66EA-4D6A-A8A7-9C9BEADD6B50}" type="datetimeFigureOut">
               <a:rPr lang="en-SE" smtClean="0"/>
-              <a:t>2024-02-01</a:t>
+              <a:t>2026-04-05</a:t>
             </a:fld>
             <a:endParaRPr lang="en-SE"/>
           </a:p>
@@ -1436,7 +1438,7 @@
           <a:p>
             <a:fld id="{024B8AE9-66EA-4D6A-A8A7-9C9BEADD6B50}" type="datetimeFigureOut">
               <a:rPr lang="en-SE" smtClean="0"/>
-              <a:t>2024-02-01</a:t>
+              <a:t>2026-04-05</a:t>
             </a:fld>
             <a:endParaRPr lang="en-SE"/>
           </a:p>
@@ -1803,7 +1805,7 @@
           <a:p>
             <a:fld id="{024B8AE9-66EA-4D6A-A8A7-9C9BEADD6B50}" type="datetimeFigureOut">
               <a:rPr lang="en-SE" smtClean="0"/>
-              <a:t>2024-02-01</a:t>
+              <a:t>2026-04-05</a:t>
             </a:fld>
             <a:endParaRPr lang="en-SE"/>
           </a:p>
@@ -1921,7 +1923,7 @@
           <a:p>
             <a:fld id="{024B8AE9-66EA-4D6A-A8A7-9C9BEADD6B50}" type="datetimeFigureOut">
               <a:rPr lang="en-SE" smtClean="0"/>
-              <a:t>2024-02-01</a:t>
+              <a:t>2026-04-05</a:t>
             </a:fld>
             <a:endParaRPr lang="en-SE"/>
           </a:p>
@@ -2016,7 +2018,7 @@
           <a:p>
             <a:fld id="{024B8AE9-66EA-4D6A-A8A7-9C9BEADD6B50}" type="datetimeFigureOut">
               <a:rPr lang="en-SE" smtClean="0"/>
-              <a:t>2024-02-01</a:t>
+              <a:t>2026-04-05</a:t>
             </a:fld>
             <a:endParaRPr lang="en-SE"/>
           </a:p>
@@ -2293,7 +2295,7 @@
           <a:p>
             <a:fld id="{024B8AE9-66EA-4D6A-A8A7-9C9BEADD6B50}" type="datetimeFigureOut">
               <a:rPr lang="en-SE" smtClean="0"/>
-              <a:t>2024-02-01</a:t>
+              <a:t>2026-04-05</a:t>
             </a:fld>
             <a:endParaRPr lang="en-SE"/>
           </a:p>
@@ -2550,7 +2552,7 @@
           <a:p>
             <a:fld id="{024B8AE9-66EA-4D6A-A8A7-9C9BEADD6B50}" type="datetimeFigureOut">
               <a:rPr lang="en-SE" smtClean="0"/>
-              <a:t>2024-02-01</a:t>
+              <a:t>2026-04-05</a:t>
             </a:fld>
             <a:endParaRPr lang="en-SE"/>
           </a:p>
@@ -2763,7 +2765,7 @@
           <a:p>
             <a:fld id="{024B8AE9-66EA-4D6A-A8A7-9C9BEADD6B50}" type="datetimeFigureOut">
               <a:rPr lang="en-SE" smtClean="0"/>
-              <a:t>2024-02-01</a:t>
+              <a:t>2026-04-05</a:t>
             </a:fld>
             <a:endParaRPr lang="en-SE"/>
           </a:p>
@@ -3222,7 +3224,13 @@
   <p:cSld>
     <p:spTree>
       <p:nvGrpSpPr>
-        <p:cNvPr id="1" name=""/>
+        <p:cNvPr id="1" name="">
+          <a:extLst>
+            <a:ext uri="{FF2B5EF4-FFF2-40B4-BE49-F238E27FC236}">
+              <a16:creationId xmlns:a16="http://schemas.microsoft.com/office/drawing/2014/main" id="{F4508271-08A4-4B97-79DB-36D31A937FDA}"/>
+            </a:ext>
+          </a:extLst>
+        </p:cNvPr>
         <p:cNvGrpSpPr/>
         <p:nvPr/>
       </p:nvGrpSpPr>
@@ -3239,7 +3247,7 @@
           <p:cNvPr id="2" name="Picture 1" descr="A colorful smoke on a black background&#10;&#10;Description automatically generated">
             <a:extLst>
               <a:ext uri="{FF2B5EF4-FFF2-40B4-BE49-F238E27FC236}">
-                <a16:creationId xmlns:a16="http://schemas.microsoft.com/office/drawing/2014/main" id="{632986F5-F442-0F89-C91C-356012685765}"/>
+                <a16:creationId xmlns:a16="http://schemas.microsoft.com/office/drawing/2014/main" id="{D9C2280F-2CBC-96D6-8867-98221A80FF5A}"/>
               </a:ext>
             </a:extLst>
           </p:cNvPr>
@@ -3270,64 +3278,10 @@
           </a:prstGeom>
         </p:spPr>
       </p:pic>
-      <p:sp>
-        <p:nvSpPr>
-          <p:cNvPr id="3" name="Rectangle 2">
-            <a:extLst>
-              <a:ext uri="{FF2B5EF4-FFF2-40B4-BE49-F238E27FC236}">
-                <a16:creationId xmlns:a16="http://schemas.microsoft.com/office/drawing/2014/main" id="{0EEB4A34-4813-8107-E073-E4629C1683CC}"/>
-              </a:ext>
-            </a:extLst>
-          </p:cNvPr>
-          <p:cNvSpPr/>
-          <p:nvPr/>
-        </p:nvSpPr>
-        <p:spPr>
-          <a:xfrm>
-            <a:off x="4286250" y="0"/>
-            <a:ext cx="285750" cy="3048000"/>
-          </a:xfrm>
-          <a:prstGeom prst="rect">
-            <a:avLst/>
-          </a:prstGeom>
-          <a:solidFill>
-            <a:srgbClr val="FF0000">
-              <a:alpha val="25000"/>
-            </a:srgbClr>
-          </a:solidFill>
-          <a:ln>
-            <a:noFill/>
-          </a:ln>
-        </p:spPr>
-        <p:style>
-          <a:lnRef idx="2">
-            <a:schemeClr val="accent1">
-              <a:shade val="15000"/>
-            </a:schemeClr>
-          </a:lnRef>
-          <a:fillRef idx="1">
-            <a:schemeClr val="accent1"/>
-          </a:fillRef>
-          <a:effectRef idx="0">
-            <a:schemeClr val="accent1"/>
-          </a:effectRef>
-          <a:fontRef idx="minor">
-            <a:schemeClr val="lt1"/>
-          </a:fontRef>
-        </p:style>
-        <p:txBody>
-          <a:bodyPr vert="vert270" lIns="0" tIns="0" rIns="0" bIns="0" rtlCol="0" anchor="ctr"/>
-          <a:lstStyle/>
-          <a:p>
-            <a:pPr algn="ctr"/>
-            <a:endParaRPr lang="en-SE" dirty="0"/>
-          </a:p>
-        </p:txBody>
-      </p:sp>
     </p:spTree>
     <p:extLst>
       <p:ext uri="{BB962C8B-B14F-4D97-AF65-F5344CB8AC3E}">
-        <p14:creationId xmlns:p14="http://schemas.microsoft.com/office/powerpoint/2010/main" val="2904208445"/>
+        <p14:creationId xmlns:p14="http://schemas.microsoft.com/office/powerpoint/2010/main" val="181599506"/>
       </p:ext>
     </p:extLst>
   </p:cSld>
@@ -3390,6 +3344,1003 @@
           </a:prstGeom>
         </p:spPr>
       </p:pic>
+      <p:sp>
+        <p:nvSpPr>
+          <p:cNvPr id="3" name="Rectangle 2">
+            <a:extLst>
+              <a:ext uri="{FF2B5EF4-FFF2-40B4-BE49-F238E27FC236}">
+                <a16:creationId xmlns:a16="http://schemas.microsoft.com/office/drawing/2014/main" id="{0EEB4A34-4813-8107-E073-E4629C1683CC}"/>
+              </a:ext>
+            </a:extLst>
+          </p:cNvPr>
+          <p:cNvSpPr/>
+          <p:nvPr/>
+        </p:nvSpPr>
+        <p:spPr>
+          <a:xfrm>
+            <a:off x="4286250" y="0"/>
+            <a:ext cx="285750" cy="3048000"/>
+          </a:xfrm>
+          <a:prstGeom prst="rect">
+            <a:avLst/>
+          </a:prstGeom>
+          <a:solidFill>
+            <a:srgbClr val="FF0000">
+              <a:alpha val="25000"/>
+            </a:srgbClr>
+          </a:solidFill>
+          <a:ln>
+            <a:noFill/>
+          </a:ln>
+        </p:spPr>
+        <p:style>
+          <a:lnRef idx="2">
+            <a:schemeClr val="accent1">
+              <a:shade val="15000"/>
+            </a:schemeClr>
+          </a:lnRef>
+          <a:fillRef idx="1">
+            <a:schemeClr val="accent1"/>
+          </a:fillRef>
+          <a:effectRef idx="0">
+            <a:schemeClr val="accent1"/>
+          </a:effectRef>
+          <a:fontRef idx="minor">
+            <a:schemeClr val="lt1"/>
+          </a:fontRef>
+        </p:style>
+        <p:txBody>
+          <a:bodyPr vert="vert270" lIns="0" tIns="0" rIns="0" bIns="0" rtlCol="0" anchor="ctr"/>
+          <a:lstStyle/>
+          <a:p>
+            <a:pPr algn="ctr"/>
+            <a:endParaRPr lang="en-SE" dirty="0"/>
+          </a:p>
+        </p:txBody>
+      </p:sp>
+      <p:grpSp>
+        <p:nvGrpSpPr>
+          <p:cNvPr id="4" name="Group 3">
+            <a:extLst>
+              <a:ext uri="{FF2B5EF4-FFF2-40B4-BE49-F238E27FC236}">
+                <a16:creationId xmlns:a16="http://schemas.microsoft.com/office/drawing/2014/main" id="{29FF4B23-42DF-DB20-35D8-8CB9CB46AEFF}"/>
+              </a:ext>
+            </a:extLst>
+          </p:cNvPr>
+          <p:cNvGrpSpPr/>
+          <p:nvPr/>
+        </p:nvGrpSpPr>
+        <p:grpSpPr>
+          <a:xfrm>
+            <a:off x="653082" y="425450"/>
+            <a:ext cx="953468" cy="952500"/>
+            <a:chOff x="4410075" y="1238250"/>
+            <a:chExt cx="953468" cy="952500"/>
+          </a:xfrm>
+        </p:grpSpPr>
+        <p:sp>
+          <p:nvSpPr>
+            <p:cNvPr id="5" name="Rectangle 4">
+              <a:extLst>
+                <a:ext uri="{FF2B5EF4-FFF2-40B4-BE49-F238E27FC236}">
+                  <a16:creationId xmlns:a16="http://schemas.microsoft.com/office/drawing/2014/main" id="{5CCBABCA-3322-DB29-E531-EB150F7E3893}"/>
+                </a:ext>
+              </a:extLst>
+            </p:cNvPr>
+            <p:cNvSpPr/>
+            <p:nvPr/>
+          </p:nvSpPr>
+          <p:spPr>
+            <a:xfrm>
+              <a:off x="4410075" y="1238250"/>
+              <a:ext cx="952500" cy="952500"/>
+            </a:xfrm>
+            <a:prstGeom prst="rect">
+              <a:avLst/>
+            </a:prstGeom>
+            <a:solidFill>
+              <a:schemeClr val="tx1"/>
+            </a:solidFill>
+            <a:ln>
+              <a:solidFill>
+                <a:schemeClr val="tx1"/>
+              </a:solidFill>
+            </a:ln>
+          </p:spPr>
+          <p:style>
+            <a:lnRef idx="2">
+              <a:schemeClr val="accent1">
+                <a:shade val="15000"/>
+              </a:schemeClr>
+            </a:lnRef>
+            <a:fillRef idx="1">
+              <a:schemeClr val="accent1"/>
+            </a:fillRef>
+            <a:effectRef idx="0">
+              <a:schemeClr val="accent1"/>
+            </a:effectRef>
+            <a:fontRef idx="minor">
+              <a:schemeClr val="lt1"/>
+            </a:fontRef>
+          </p:style>
+          <p:txBody>
+            <a:bodyPr rtlCol="0" anchor="ctr"/>
+            <a:lstStyle/>
+            <a:p>
+              <a:pPr algn="ctr"/>
+              <a:endParaRPr lang="en-SE"/>
+            </a:p>
+          </p:txBody>
+        </p:sp>
+        <p:sp>
+          <p:nvSpPr>
+            <p:cNvPr id="6" name="Star: 5 Points 5">
+              <a:extLst>
+                <a:ext uri="{FF2B5EF4-FFF2-40B4-BE49-F238E27FC236}">
+                  <a16:creationId xmlns:a16="http://schemas.microsoft.com/office/drawing/2014/main" id="{A779330B-1904-7259-D6F1-20B6BFFC0F39}"/>
+                </a:ext>
+              </a:extLst>
+            </p:cNvPr>
+            <p:cNvSpPr>
+              <a:spLocks noChangeAspect="1"/>
+            </p:cNvSpPr>
+            <p:nvPr/>
+          </p:nvSpPr>
+          <p:spPr>
+            <a:xfrm>
+              <a:off x="5265441" y="2026850"/>
+              <a:ext cx="50400" cy="50400"/>
+            </a:xfrm>
+            <a:prstGeom prst="star5">
+              <a:avLst/>
+            </a:prstGeom>
+            <a:solidFill>
+              <a:srgbClr val="F4EF21"/>
+            </a:solidFill>
+            <a:ln>
+              <a:noFill/>
+            </a:ln>
+          </p:spPr>
+          <p:style>
+            <a:lnRef idx="2">
+              <a:schemeClr val="accent1">
+                <a:shade val="15000"/>
+              </a:schemeClr>
+            </a:lnRef>
+            <a:fillRef idx="1">
+              <a:schemeClr val="accent1"/>
+            </a:fillRef>
+            <a:effectRef idx="0">
+              <a:schemeClr val="accent1"/>
+            </a:effectRef>
+            <a:fontRef idx="minor">
+              <a:schemeClr val="lt1"/>
+            </a:fontRef>
+          </p:style>
+          <p:txBody>
+            <a:bodyPr rtlCol="0" anchor="ctr"/>
+            <a:lstStyle/>
+            <a:p>
+              <a:pPr algn="ctr"/>
+              <a:endParaRPr lang="en-SE"/>
+            </a:p>
+          </p:txBody>
+        </p:sp>
+        <p:sp>
+          <p:nvSpPr>
+            <p:cNvPr id="7" name="Oval 6">
+              <a:extLst>
+                <a:ext uri="{FF2B5EF4-FFF2-40B4-BE49-F238E27FC236}">
+                  <a16:creationId xmlns:a16="http://schemas.microsoft.com/office/drawing/2014/main" id="{876DFFB6-2718-21C0-0D7E-B9A522561064}"/>
+                </a:ext>
+              </a:extLst>
+            </p:cNvPr>
+            <p:cNvSpPr/>
+            <p:nvPr/>
+          </p:nvSpPr>
+          <p:spPr>
+            <a:xfrm>
+              <a:off x="4454222" y="1282500"/>
+              <a:ext cx="864000" cy="864000"/>
+            </a:xfrm>
+            <a:prstGeom prst="ellipse">
+              <a:avLst/>
+            </a:prstGeom>
+            <a:solidFill>
+              <a:schemeClr val="tx1"/>
+            </a:solidFill>
+            <a:ln>
+              <a:solidFill>
+                <a:schemeClr val="tx1"/>
+              </a:solidFill>
+            </a:ln>
+          </p:spPr>
+          <p:style>
+            <a:lnRef idx="2">
+              <a:schemeClr val="accent1">
+                <a:shade val="15000"/>
+              </a:schemeClr>
+            </a:lnRef>
+            <a:fillRef idx="1">
+              <a:schemeClr val="accent1"/>
+            </a:fillRef>
+            <a:effectRef idx="0">
+              <a:schemeClr val="accent1"/>
+            </a:effectRef>
+            <a:fontRef idx="minor">
+              <a:schemeClr val="lt1"/>
+            </a:fontRef>
+          </p:style>
+          <p:txBody>
+            <a:bodyPr rtlCol="0" anchor="ctr"/>
+            <a:lstStyle/>
+            <a:p>
+              <a:pPr algn="ctr"/>
+              <a:endParaRPr lang="en-SE"/>
+            </a:p>
+          </p:txBody>
+        </p:sp>
+        <p:sp>
+          <p:nvSpPr>
+            <p:cNvPr id="8" name="Star: 5 Points 7">
+              <a:extLst>
+                <a:ext uri="{FF2B5EF4-FFF2-40B4-BE49-F238E27FC236}">
+                  <a16:creationId xmlns:a16="http://schemas.microsoft.com/office/drawing/2014/main" id="{76955530-2BE1-69B4-075C-83FE7F6D09E2}"/>
+                </a:ext>
+              </a:extLst>
+            </p:cNvPr>
+            <p:cNvSpPr>
+              <a:spLocks noChangeAspect="1"/>
+            </p:cNvSpPr>
+            <p:nvPr/>
+          </p:nvSpPr>
+          <p:spPr>
+            <a:xfrm>
+              <a:off x="4428919" y="2121300"/>
+              <a:ext cx="50400" cy="50400"/>
+            </a:xfrm>
+            <a:prstGeom prst="star5">
+              <a:avLst/>
+            </a:prstGeom>
+            <a:solidFill>
+              <a:srgbClr val="F4EF21"/>
+            </a:solidFill>
+            <a:ln>
+              <a:noFill/>
+            </a:ln>
+          </p:spPr>
+          <p:style>
+            <a:lnRef idx="2">
+              <a:schemeClr val="accent1">
+                <a:shade val="15000"/>
+              </a:schemeClr>
+            </a:lnRef>
+            <a:fillRef idx="1">
+              <a:schemeClr val="accent1"/>
+            </a:fillRef>
+            <a:effectRef idx="0">
+              <a:schemeClr val="accent1"/>
+            </a:effectRef>
+            <a:fontRef idx="minor">
+              <a:schemeClr val="lt1"/>
+            </a:fontRef>
+          </p:style>
+          <p:txBody>
+            <a:bodyPr rtlCol="0" anchor="ctr"/>
+            <a:lstStyle/>
+            <a:p>
+              <a:pPr algn="ctr"/>
+              <a:endParaRPr lang="en-SE"/>
+            </a:p>
+          </p:txBody>
+        </p:sp>
+        <p:sp>
+          <p:nvSpPr>
+            <p:cNvPr id="9" name="Star: 5 Points 8">
+              <a:extLst>
+                <a:ext uri="{FF2B5EF4-FFF2-40B4-BE49-F238E27FC236}">
+                  <a16:creationId xmlns:a16="http://schemas.microsoft.com/office/drawing/2014/main" id="{4F211577-EE3A-E802-F3DA-B738BF740654}"/>
+                </a:ext>
+              </a:extLst>
+            </p:cNvPr>
+            <p:cNvSpPr>
+              <a:spLocks noChangeAspect="1"/>
+            </p:cNvSpPr>
+            <p:nvPr/>
+          </p:nvSpPr>
+          <p:spPr>
+            <a:xfrm>
+              <a:off x="4484651" y="2008100"/>
+              <a:ext cx="50400" cy="50400"/>
+            </a:xfrm>
+            <a:prstGeom prst="star5">
+              <a:avLst/>
+            </a:prstGeom>
+            <a:solidFill>
+              <a:srgbClr val="F4EF21"/>
+            </a:solidFill>
+            <a:ln>
+              <a:noFill/>
+            </a:ln>
+          </p:spPr>
+          <p:style>
+            <a:lnRef idx="2">
+              <a:schemeClr val="accent1">
+                <a:shade val="15000"/>
+              </a:schemeClr>
+            </a:lnRef>
+            <a:fillRef idx="1">
+              <a:schemeClr val="accent1"/>
+            </a:fillRef>
+            <a:effectRef idx="0">
+              <a:schemeClr val="accent1"/>
+            </a:effectRef>
+            <a:fontRef idx="minor">
+              <a:schemeClr val="lt1"/>
+            </a:fontRef>
+          </p:style>
+          <p:txBody>
+            <a:bodyPr rtlCol="0" anchor="ctr"/>
+            <a:lstStyle/>
+            <a:p>
+              <a:pPr algn="ctr"/>
+              <a:endParaRPr lang="en-SE"/>
+            </a:p>
+          </p:txBody>
+        </p:sp>
+        <p:sp>
+          <p:nvSpPr>
+            <p:cNvPr id="10" name="Star: 5 Points 9">
+              <a:extLst>
+                <a:ext uri="{FF2B5EF4-FFF2-40B4-BE49-F238E27FC236}">
+                  <a16:creationId xmlns:a16="http://schemas.microsoft.com/office/drawing/2014/main" id="{4DA901C7-FA40-9851-91EE-E29821E176EC}"/>
+                </a:ext>
+              </a:extLst>
+            </p:cNvPr>
+            <p:cNvSpPr>
+              <a:spLocks noChangeAspect="1"/>
+            </p:cNvSpPr>
+            <p:nvPr/>
+          </p:nvSpPr>
+          <p:spPr>
+            <a:xfrm>
+              <a:off x="4547381" y="1474949"/>
+              <a:ext cx="50400" cy="50400"/>
+            </a:xfrm>
+            <a:prstGeom prst="star5">
+              <a:avLst/>
+            </a:prstGeom>
+            <a:solidFill>
+              <a:srgbClr val="F4EF21"/>
+            </a:solidFill>
+            <a:ln>
+              <a:noFill/>
+            </a:ln>
+          </p:spPr>
+          <p:style>
+            <a:lnRef idx="2">
+              <a:schemeClr val="accent1">
+                <a:shade val="15000"/>
+              </a:schemeClr>
+            </a:lnRef>
+            <a:fillRef idx="1">
+              <a:schemeClr val="accent1"/>
+            </a:fillRef>
+            <a:effectRef idx="0">
+              <a:schemeClr val="accent1"/>
+            </a:effectRef>
+            <a:fontRef idx="minor">
+              <a:schemeClr val="lt1"/>
+            </a:fontRef>
+          </p:style>
+          <p:txBody>
+            <a:bodyPr rtlCol="0" anchor="ctr"/>
+            <a:lstStyle/>
+            <a:p>
+              <a:pPr algn="ctr"/>
+              <a:endParaRPr lang="en-SE"/>
+            </a:p>
+          </p:txBody>
+        </p:sp>
+        <p:sp>
+          <p:nvSpPr>
+            <p:cNvPr id="11" name="Oval 10">
+              <a:extLst>
+                <a:ext uri="{FF2B5EF4-FFF2-40B4-BE49-F238E27FC236}">
+                  <a16:creationId xmlns:a16="http://schemas.microsoft.com/office/drawing/2014/main" id="{1893BE86-955A-5395-25DD-0641F357DB0E}"/>
+                </a:ext>
+              </a:extLst>
+            </p:cNvPr>
+            <p:cNvSpPr/>
+            <p:nvPr/>
+          </p:nvSpPr>
+          <p:spPr>
+            <a:xfrm>
+              <a:off x="4539462" y="1533450"/>
+              <a:ext cx="518400" cy="518400"/>
+            </a:xfrm>
+            <a:prstGeom prst="ellipse">
+              <a:avLst/>
+            </a:prstGeom>
+            <a:solidFill>
+              <a:srgbClr val="B4CBD5"/>
+            </a:solidFill>
+            <a:ln>
+              <a:solidFill>
+                <a:srgbClr val="B4CBD5"/>
+              </a:solidFill>
+            </a:ln>
+          </p:spPr>
+          <p:style>
+            <a:lnRef idx="2">
+              <a:schemeClr val="accent1">
+                <a:shade val="15000"/>
+              </a:schemeClr>
+            </a:lnRef>
+            <a:fillRef idx="1">
+              <a:schemeClr val="accent1"/>
+            </a:fillRef>
+            <a:effectRef idx="0">
+              <a:schemeClr val="accent1"/>
+            </a:effectRef>
+            <a:fontRef idx="minor">
+              <a:schemeClr val="lt1"/>
+            </a:fontRef>
+          </p:style>
+          <p:txBody>
+            <a:bodyPr rtlCol="0" anchor="ctr"/>
+            <a:lstStyle/>
+            <a:p>
+              <a:pPr algn="ctr"/>
+              <a:endParaRPr lang="en-SE"/>
+            </a:p>
+          </p:txBody>
+        </p:sp>
+        <p:sp>
+          <p:nvSpPr>
+            <p:cNvPr id="12" name="Oval 11">
+              <a:extLst>
+                <a:ext uri="{FF2B5EF4-FFF2-40B4-BE49-F238E27FC236}">
+                  <a16:creationId xmlns:a16="http://schemas.microsoft.com/office/drawing/2014/main" id="{0E5EE037-22A5-C5E9-7965-C0ED12F3BEB8}"/>
+                </a:ext>
+              </a:extLst>
+            </p:cNvPr>
+            <p:cNvSpPr>
+              <a:spLocks noChangeAspect="1"/>
+            </p:cNvSpPr>
+            <p:nvPr/>
+          </p:nvSpPr>
+          <p:spPr>
+            <a:xfrm>
+              <a:off x="4696793" y="1336048"/>
+              <a:ext cx="666750" cy="666750"/>
+            </a:xfrm>
+            <a:prstGeom prst="ellipse">
+              <a:avLst/>
+            </a:prstGeom>
+            <a:solidFill>
+              <a:schemeClr val="tx1"/>
+            </a:solidFill>
+            <a:ln>
+              <a:solidFill>
+                <a:schemeClr val="tx1"/>
+              </a:solidFill>
+            </a:ln>
+          </p:spPr>
+          <p:style>
+            <a:lnRef idx="2">
+              <a:schemeClr val="accent1">
+                <a:shade val="15000"/>
+              </a:schemeClr>
+            </a:lnRef>
+            <a:fillRef idx="1">
+              <a:schemeClr val="accent1"/>
+            </a:fillRef>
+            <a:effectRef idx="0">
+              <a:schemeClr val="accent1"/>
+            </a:effectRef>
+            <a:fontRef idx="minor">
+              <a:schemeClr val="lt1"/>
+            </a:fontRef>
+          </p:style>
+          <p:txBody>
+            <a:bodyPr rtlCol="0" anchor="ctr"/>
+            <a:lstStyle/>
+            <a:p>
+              <a:pPr algn="ctr"/>
+              <a:endParaRPr lang="en-SE"/>
+            </a:p>
+          </p:txBody>
+        </p:sp>
+        <p:sp>
+          <p:nvSpPr>
+            <p:cNvPr id="13" name="Star: 5 Points 12">
+              <a:extLst>
+                <a:ext uri="{FF2B5EF4-FFF2-40B4-BE49-F238E27FC236}">
+                  <a16:creationId xmlns:a16="http://schemas.microsoft.com/office/drawing/2014/main" id="{AB6D7658-284F-E7BE-17F4-B4D9BCD9C1CE}"/>
+                </a:ext>
+              </a:extLst>
+            </p:cNvPr>
+            <p:cNvSpPr>
+              <a:spLocks noChangeAspect="1"/>
+            </p:cNvSpPr>
+            <p:nvPr/>
+          </p:nvSpPr>
+          <p:spPr>
+            <a:xfrm>
+              <a:off x="5036994" y="1336048"/>
+              <a:ext cx="63000" cy="63000"/>
+            </a:xfrm>
+            <a:prstGeom prst="star5">
+              <a:avLst/>
+            </a:prstGeom>
+            <a:solidFill>
+              <a:srgbClr val="F4EF21"/>
+            </a:solidFill>
+            <a:ln>
+              <a:noFill/>
+            </a:ln>
+          </p:spPr>
+          <p:style>
+            <a:lnRef idx="2">
+              <a:schemeClr val="accent1">
+                <a:shade val="15000"/>
+              </a:schemeClr>
+            </a:lnRef>
+            <a:fillRef idx="1">
+              <a:schemeClr val="accent1"/>
+            </a:fillRef>
+            <a:effectRef idx="0">
+              <a:schemeClr val="accent1"/>
+            </a:effectRef>
+            <a:fontRef idx="minor">
+              <a:schemeClr val="lt1"/>
+            </a:fontRef>
+          </p:style>
+          <p:txBody>
+            <a:bodyPr rtlCol="0" anchor="ctr"/>
+            <a:lstStyle/>
+            <a:p>
+              <a:pPr algn="ctr"/>
+              <a:endParaRPr lang="en-SE"/>
+            </a:p>
+          </p:txBody>
+        </p:sp>
+      </p:grpSp>
+      <p:pic>
+        <p:nvPicPr>
+          <p:cNvPr id="15" name="Picture 14">
+            <a:extLst>
+              <a:ext uri="{FF2B5EF4-FFF2-40B4-BE49-F238E27FC236}">
+                <a16:creationId xmlns:a16="http://schemas.microsoft.com/office/drawing/2014/main" id="{7A151D3A-0679-D605-4111-57ECCD186984}"/>
+              </a:ext>
+            </a:extLst>
+          </p:cNvPr>
+          <p:cNvPicPr>
+            <a:picLocks noChangeAspect="1"/>
+          </p:cNvPicPr>
+          <p:nvPr/>
+        </p:nvPicPr>
+        <p:blipFill>
+          <a:blip r:embed="rId3">
+            <a:clrChange>
+              <a:clrFrom>
+                <a:srgbClr val="000000"/>
+              </a:clrFrom>
+              <a:clrTo>
+                <a:srgbClr val="000000">
+                  <a:alpha val="0"/>
+                </a:srgbClr>
+              </a:clrTo>
+            </a:clrChange>
+          </a:blip>
+          <a:stretch>
+            <a:fillRect/>
+          </a:stretch>
+        </p:blipFill>
+        <p:spPr>
+          <a:xfrm>
+            <a:off x="1548028" y="1333700"/>
+            <a:ext cx="952500" cy="952500"/>
+          </a:xfrm>
+          <a:prstGeom prst="rect">
+            <a:avLst/>
+          </a:prstGeom>
+        </p:spPr>
+      </p:pic>
+    </p:spTree>
+    <p:extLst>
+      <p:ext uri="{BB962C8B-B14F-4D97-AF65-F5344CB8AC3E}">
+        <p14:creationId xmlns:p14="http://schemas.microsoft.com/office/powerpoint/2010/main" val="2904208445"/>
+      </p:ext>
+    </p:extLst>
+  </p:cSld>
+  <p:clrMapOvr>
+    <a:masterClrMapping/>
+  </p:clrMapOvr>
+</p:sld>
+</file>
+
+<file path=ppt/slides/slide4.xml><?xml version="1.0" encoding="utf-8"?>
+<p:sld xmlns:a="http://schemas.openxmlformats.org/drawingml/2006/main" xmlns:r="http://schemas.openxmlformats.org/officeDocument/2006/relationships" xmlns:p="http://schemas.openxmlformats.org/presentationml/2006/main">
+  <p:cSld>
+    <p:spTree>
+      <p:nvGrpSpPr>
+        <p:cNvPr id="1" name="">
+          <a:extLst>
+            <a:ext uri="{FF2B5EF4-FFF2-40B4-BE49-F238E27FC236}">
+              <a16:creationId xmlns:a16="http://schemas.microsoft.com/office/drawing/2014/main" id="{B00B1839-0E9F-307A-F336-B2A1ACFD7EF6}"/>
+            </a:ext>
+          </a:extLst>
+        </p:cNvPr>
+        <p:cNvGrpSpPr/>
+        <p:nvPr/>
+      </p:nvGrpSpPr>
+      <p:grpSpPr>
+        <a:xfrm>
+          <a:off x="0" y="0"/>
+          <a:ext cx="0" cy="0"/>
+          <a:chOff x="0" y="0"/>
+          <a:chExt cx="0" cy="0"/>
+        </a:xfrm>
+      </p:grpSpPr>
+      <p:pic>
+        <p:nvPicPr>
+          <p:cNvPr id="2" name="Picture 1" descr="A colorful smoke on a black background&#10;&#10;Description automatically generated">
+            <a:extLst>
+              <a:ext uri="{FF2B5EF4-FFF2-40B4-BE49-F238E27FC236}">
+                <a16:creationId xmlns:a16="http://schemas.microsoft.com/office/drawing/2014/main" id="{4AA93F65-2201-2D6D-8FAA-A12765267079}"/>
+              </a:ext>
+            </a:extLst>
+          </p:cNvPr>
+          <p:cNvPicPr>
+            <a:picLocks noChangeAspect="1"/>
+          </p:cNvPicPr>
+          <p:nvPr/>
+        </p:nvPicPr>
+        <p:blipFill>
+          <a:blip r:embed="rId2">
+            <a:extLst>
+              <a:ext uri="{28A0092B-C50C-407E-A947-70E740481C1C}">
+                <a14:useLocalDpi xmlns:a14="http://schemas.microsoft.com/office/drawing/2010/main" val="0"/>
+              </a:ext>
+            </a:extLst>
+          </a:blip>
+          <a:stretch>
+            <a:fillRect/>
+          </a:stretch>
+        </p:blipFill>
+        <p:spPr>
+          <a:xfrm>
+            <a:off x="0" y="0"/>
+            <a:ext cx="4572000" cy="3048000"/>
+          </a:xfrm>
+          <a:prstGeom prst="rect">
+            <a:avLst/>
+          </a:prstGeom>
+        </p:spPr>
+      </p:pic>
+      <p:sp>
+        <p:nvSpPr>
+          <p:cNvPr id="3" name="Rectangle 2">
+            <a:extLst>
+              <a:ext uri="{FF2B5EF4-FFF2-40B4-BE49-F238E27FC236}">
+                <a16:creationId xmlns:a16="http://schemas.microsoft.com/office/drawing/2014/main" id="{D9E23A2A-0B3A-46CA-4146-F61419F78A8E}"/>
+              </a:ext>
+            </a:extLst>
+          </p:cNvPr>
+          <p:cNvSpPr/>
+          <p:nvPr/>
+        </p:nvSpPr>
+        <p:spPr>
+          <a:xfrm>
+            <a:off x="4286250" y="0"/>
+            <a:ext cx="285750" cy="3048000"/>
+          </a:xfrm>
+          <a:prstGeom prst="rect">
+            <a:avLst/>
+          </a:prstGeom>
+          <a:solidFill>
+            <a:srgbClr val="FF0000">
+              <a:alpha val="25000"/>
+            </a:srgbClr>
+          </a:solidFill>
+          <a:ln>
+            <a:noFill/>
+          </a:ln>
+        </p:spPr>
+        <p:style>
+          <a:lnRef idx="2">
+            <a:schemeClr val="accent1">
+              <a:shade val="15000"/>
+            </a:schemeClr>
+          </a:lnRef>
+          <a:fillRef idx="1">
+            <a:schemeClr val="accent1"/>
+          </a:fillRef>
+          <a:effectRef idx="0">
+            <a:schemeClr val="accent1"/>
+          </a:effectRef>
+          <a:fontRef idx="minor">
+            <a:schemeClr val="lt1"/>
+          </a:fontRef>
+        </p:style>
+        <p:txBody>
+          <a:bodyPr vert="vert270" lIns="0" tIns="0" rIns="0" bIns="0" rtlCol="0" anchor="ctr"/>
+          <a:lstStyle/>
+          <a:p>
+            <a:pPr algn="ctr"/>
+            <a:endParaRPr lang="en-SE" dirty="0"/>
+          </a:p>
+        </p:txBody>
+      </p:sp>
+      <p:pic>
+        <p:nvPicPr>
+          <p:cNvPr id="5" name="Picture 4">
+            <a:extLst>
+              <a:ext uri="{FF2B5EF4-FFF2-40B4-BE49-F238E27FC236}">
+                <a16:creationId xmlns:a16="http://schemas.microsoft.com/office/drawing/2014/main" id="{F2F136DC-3311-4C73-99B8-00B804D91DE0}"/>
+              </a:ext>
+            </a:extLst>
+          </p:cNvPr>
+          <p:cNvPicPr>
+            <a:picLocks noChangeAspect="1"/>
+          </p:cNvPicPr>
+          <p:nvPr/>
+        </p:nvPicPr>
+        <p:blipFill>
+          <a:blip r:embed="rId3">
+            <a:extLst>
+              <a:ext uri="{28A0092B-C50C-407E-A947-70E740481C1C}">
+                <a14:useLocalDpi xmlns:a14="http://schemas.microsoft.com/office/drawing/2010/main" val="0"/>
+              </a:ext>
+            </a:extLst>
+          </a:blip>
+          <a:stretch>
+            <a:fillRect/>
+          </a:stretch>
+        </p:blipFill>
+        <p:spPr>
+          <a:xfrm>
+            <a:off x="285" y="190"/>
+            <a:ext cx="4571429" cy="3047619"/>
+          </a:xfrm>
+          <a:prstGeom prst="rect">
+            <a:avLst/>
+          </a:prstGeom>
+        </p:spPr>
+      </p:pic>
+      <p:sp>
+        <p:nvSpPr>
+          <p:cNvPr id="7" name="Rectangle: Rounded Corners 6">
+            <a:extLst>
+              <a:ext uri="{FF2B5EF4-FFF2-40B4-BE49-F238E27FC236}">
+                <a16:creationId xmlns:a16="http://schemas.microsoft.com/office/drawing/2014/main" id="{734A28AF-C7A7-88B2-16B3-98E9EC04CB70}"/>
+              </a:ext>
+            </a:extLst>
+          </p:cNvPr>
+          <p:cNvSpPr/>
+          <p:nvPr/>
+        </p:nvSpPr>
+        <p:spPr>
+          <a:xfrm>
+            <a:off x="1363363" y="1912143"/>
+            <a:ext cx="2370437" cy="65882"/>
+          </a:xfrm>
+          <a:prstGeom prst="roundRect">
+            <a:avLst>
+              <a:gd name="adj" fmla="val 50000"/>
+            </a:avLst>
+          </a:prstGeom>
+          <a:ln>
+            <a:noFill/>
+          </a:ln>
+          <a:effectLst>
+            <a:softEdge rad="0"/>
+          </a:effectLst>
+        </p:spPr>
+        <p:style>
+          <a:lnRef idx="2">
+            <a:schemeClr val="accent1">
+              <a:shade val="15000"/>
+            </a:schemeClr>
+          </a:lnRef>
+          <a:fillRef idx="1">
+            <a:schemeClr val="accent1"/>
+          </a:fillRef>
+          <a:effectRef idx="0">
+            <a:schemeClr val="accent1"/>
+          </a:effectRef>
+          <a:fontRef idx="minor">
+            <a:schemeClr val="lt1"/>
+          </a:fontRef>
+        </p:style>
+        <p:txBody>
+          <a:bodyPr rtlCol="0" anchor="ctr"/>
+          <a:lstStyle/>
+          <a:p>
+            <a:pPr algn="ctr"/>
+            <a:endParaRPr lang="en-SE"/>
+          </a:p>
+        </p:txBody>
+      </p:sp>
+      <p:sp>
+        <p:nvSpPr>
+          <p:cNvPr id="10" name="Rectangle: Rounded Corners 9">
+            <a:extLst>
+              <a:ext uri="{FF2B5EF4-FFF2-40B4-BE49-F238E27FC236}">
+                <a16:creationId xmlns:a16="http://schemas.microsoft.com/office/drawing/2014/main" id="{5DEC152B-BA25-9F7A-F5CC-B8EA15686A97}"/>
+              </a:ext>
+            </a:extLst>
+          </p:cNvPr>
+          <p:cNvSpPr/>
+          <p:nvPr/>
+        </p:nvSpPr>
+        <p:spPr>
+          <a:xfrm>
+            <a:off x="1363363" y="2061368"/>
+            <a:ext cx="2370437" cy="65882"/>
+          </a:xfrm>
+          <a:prstGeom prst="roundRect">
+            <a:avLst>
+              <a:gd name="adj" fmla="val 50000"/>
+            </a:avLst>
+          </a:prstGeom>
+          <a:solidFill>
+            <a:srgbClr val="666666"/>
+          </a:solidFill>
+          <a:ln>
+            <a:noFill/>
+          </a:ln>
+          <a:effectLst>
+            <a:softEdge rad="0"/>
+          </a:effectLst>
+        </p:spPr>
+        <p:style>
+          <a:lnRef idx="2">
+            <a:schemeClr val="accent1">
+              <a:shade val="15000"/>
+            </a:schemeClr>
+          </a:lnRef>
+          <a:fillRef idx="1">
+            <a:schemeClr val="accent1"/>
+          </a:fillRef>
+          <a:effectRef idx="0">
+            <a:schemeClr val="accent1"/>
+          </a:effectRef>
+          <a:fontRef idx="minor">
+            <a:schemeClr val="lt1"/>
+          </a:fontRef>
+        </p:style>
+        <p:txBody>
+          <a:bodyPr rtlCol="0" anchor="ctr"/>
+          <a:lstStyle/>
+          <a:p>
+            <a:pPr algn="ctr"/>
+            <a:endParaRPr lang="en-SE"/>
+          </a:p>
+        </p:txBody>
+      </p:sp>
+      <p:sp>
+        <p:nvSpPr>
+          <p:cNvPr id="11" name="Rectangle: Rounded Corners 10">
+            <a:extLst>
+              <a:ext uri="{FF2B5EF4-FFF2-40B4-BE49-F238E27FC236}">
+                <a16:creationId xmlns:a16="http://schemas.microsoft.com/office/drawing/2014/main" id="{87451EA5-D820-3BA8-28DF-2947C75E4986}"/>
+              </a:ext>
+            </a:extLst>
+          </p:cNvPr>
+          <p:cNvSpPr/>
+          <p:nvPr/>
+        </p:nvSpPr>
+        <p:spPr>
+          <a:xfrm>
+            <a:off x="1477663" y="1334293"/>
+            <a:ext cx="2428875" cy="65882"/>
+          </a:xfrm>
+          <a:prstGeom prst="roundRect">
+            <a:avLst>
+              <a:gd name="adj" fmla="val 50000"/>
+            </a:avLst>
+          </a:prstGeom>
+          <a:ln>
+            <a:noFill/>
+          </a:ln>
+          <a:effectLst>
+            <a:softEdge rad="0"/>
+          </a:effectLst>
+        </p:spPr>
+        <p:style>
+          <a:lnRef idx="2">
+            <a:schemeClr val="accent1">
+              <a:shade val="15000"/>
+            </a:schemeClr>
+          </a:lnRef>
+          <a:fillRef idx="1">
+            <a:schemeClr val="accent1"/>
+          </a:fillRef>
+          <a:effectRef idx="0">
+            <a:schemeClr val="accent1"/>
+          </a:effectRef>
+          <a:fontRef idx="minor">
+            <a:schemeClr val="lt1"/>
+          </a:fontRef>
+        </p:style>
+        <p:txBody>
+          <a:bodyPr rtlCol="0" anchor="ctr"/>
+          <a:lstStyle/>
+          <a:p>
+            <a:pPr algn="ctr"/>
+            <a:endParaRPr lang="en-SE"/>
+          </a:p>
+        </p:txBody>
+      </p:sp>
+    </p:spTree>
+    <p:extLst>
+      <p:ext uri="{BB962C8B-B14F-4D97-AF65-F5344CB8AC3E}">
+        <p14:creationId xmlns:p14="http://schemas.microsoft.com/office/powerpoint/2010/main" val="1756544159"/>
+      </p:ext>
+    </p:extLst>
+  </p:cSld>
+  <p:clrMapOvr>
+    <a:masterClrMapping/>
+  </p:clrMapOvr>
+</p:sld>
+</file>
+
+<file path=ppt/slides/slide5.xml><?xml version="1.0" encoding="utf-8"?>
+<p:sld xmlns:a="http://schemas.openxmlformats.org/drawingml/2006/main" xmlns:r="http://schemas.openxmlformats.org/officeDocument/2006/relationships" xmlns:p="http://schemas.openxmlformats.org/presentationml/2006/main">
+  <p:cSld>
+    <p:spTree>
+      <p:nvGrpSpPr>
+        <p:cNvPr id="1" name=""/>
+        <p:cNvGrpSpPr/>
+        <p:nvPr/>
+      </p:nvGrpSpPr>
+      <p:grpSpPr>
+        <a:xfrm>
+          <a:off x="0" y="0"/>
+          <a:ext cx="0" cy="0"/>
+          <a:chOff x="0" y="0"/>
+          <a:chExt cx="0" cy="0"/>
+        </a:xfrm>
+      </p:grpSpPr>
+      <p:pic>
+        <p:nvPicPr>
+          <p:cNvPr id="2" name="Picture 1" descr="A colorful smoke on a black background&#10;&#10;Description automatically generated">
+            <a:extLst>
+              <a:ext uri="{FF2B5EF4-FFF2-40B4-BE49-F238E27FC236}">
+                <a16:creationId xmlns:a16="http://schemas.microsoft.com/office/drawing/2014/main" id="{632986F5-F442-0F89-C91C-356012685765}"/>
+              </a:ext>
+            </a:extLst>
+          </p:cNvPr>
+          <p:cNvPicPr>
+            <a:picLocks noChangeAspect="1"/>
+          </p:cNvPicPr>
+          <p:nvPr/>
+        </p:nvPicPr>
+        <p:blipFill>
+          <a:blip r:embed="rId2">
+            <a:extLst>
+              <a:ext uri="{28A0092B-C50C-407E-A947-70E740481C1C}">
+                <a14:useLocalDpi xmlns:a14="http://schemas.microsoft.com/office/drawing/2010/main" val="0"/>
+              </a:ext>
+            </a:extLst>
+          </a:blip>
+          <a:stretch>
+            <a:fillRect/>
+          </a:stretch>
+        </p:blipFill>
+        <p:spPr>
+          <a:xfrm>
+            <a:off x="0" y="0"/>
+            <a:ext cx="4572000" cy="3048000"/>
+          </a:xfrm>
+          <a:prstGeom prst="rect">
+            <a:avLst/>
+          </a:prstGeom>
+        </p:spPr>
+      </p:pic>
       <p:pic>
         <p:nvPicPr>
           <p:cNvPr id="4" name="Picture 3" descr="A circle with a rainbow colored circle&#10;&#10;Description automatically generated with medium confidence">
@@ -3511,7 +4462,7 @@
 </p:sld>
 </file>
 
-<file path=ppt/slides/slide4.xml><?xml version="1.0" encoding="utf-8"?>
+<file path=ppt/slides/slide6.xml><?xml version="1.0" encoding="utf-8"?>
 <p:sld xmlns:a="http://schemas.openxmlformats.org/drawingml/2006/main" xmlns:r="http://schemas.openxmlformats.org/officeDocument/2006/relationships" xmlns:p="http://schemas.openxmlformats.org/presentationml/2006/main">
   <p:cSld>
     <p:spTree>
@@ -3993,7 +4944,7 @@
 </p:sld>
 </file>
 
-<file path=ppt/slides/slide5.xml><?xml version="1.0" encoding="utf-8"?>
+<file path=ppt/slides/slide7.xml><?xml version="1.0" encoding="utf-8"?>
 <p:sld xmlns:a="http://schemas.openxmlformats.org/drawingml/2006/main" xmlns:r="http://schemas.openxmlformats.org/officeDocument/2006/relationships" xmlns:p="http://schemas.openxmlformats.org/presentationml/2006/main">
   <p:cSld>
     <p:spTree>

</xml_diff>